<commit_message>
release(v2.0): 2.0.0a8, Phase 6 new skills wave 2 and library foundation (#1)
Version 2.0.0a7 -> 2.0.0a8 (tools/release.py); goldens regenerated
(PMLC_UPDATE_GOLDEN=1; md diffs version-only, html-golden hashes follow the
footer); Hazira samples re-rendered with the Phase 6 rerender-samples.sh at
SOURCE_DATE_EPOCH=1793145600 (2026-10-28), incl. the Phase 6 packs and
showcases; dashboard, register xlsx and register md regenerated. Sample
diffs are version and date only. Smoke OK (39 fixture packs, 41 Hazira
golden packs), check-samples 0 problems, focused golden/sample tests
175 passed. Full gate run by the orchestrator next.

Co-Authored-By: Claude Opus 5.5 <noreply@anthropic.com>
Claude-Session: https://claude.ai/code/session_011J2b33mikuz2J1RKTx4krR
</commit_message>
<xml_diff>
--- a/samples/2020-09-24-hazira-gas-release-fire/outputs/safety-alert.pptx
+++ b/samples/2020-09-24-hazira-gas-release-fire/outputs/safety-alert.pptx
@@ -2820,7 +2820,7 @@
                   <a:srgbClr val="1F2328"/>
                 </a:solidFill>
               </a:rPr>
-              <a:t>Generated with ProbeMatrix Learnings Coach v2.0.0a7 (open source, MIT) from a ProbeMatrix four-level human-factors investigation. ProbeMatrix by Eyekyam: ashley@eyekyam.com</a:t>
+              <a:t>Generated with ProbeMatrix Learnings Coach v2.0.0a8 (open source, MIT) from a ProbeMatrix four-level human-factors investigation. ProbeMatrix by Eyekyam: ashley@eyekyam.com</a:t>
             </a:r>
             <a:endParaRPr lang="en" sz="1200" dirty="0"/>
           </a:p>
@@ -3213,7 +3213,7 @@
                   <a:srgbClr val="57606A"/>
                 </a:solidFill>
               </a:rPr>
-              <a:t>Learning purposes: not a statutory document · Generated with ProbeMatrix Learnings Coach v2.0.0a7 (open source, MIT) from a ProbeMatrix four-level human-factors investigation. ProbeMatrix by Eyekyam: ashley@eyekyam.com</a:t>
+              <a:t>Learning purposes: not a statutory document · Generated with ProbeMatrix Learnings Coach v2.0.0a8 (open source, MIT) from a ProbeMatrix four-level human-factors investigation. ProbeMatrix by Eyekyam: ashley@eyekyam.com</a:t>
             </a:r>
             <a:endParaRPr lang="en" sz="900" dirty="0"/>
           </a:p>
@@ -3764,7 +3764,7 @@
                   <a:srgbClr val="57606A"/>
                 </a:solidFill>
               </a:rPr>
-              <a:t>Learning purposes: not a statutory document · Generated with ProbeMatrix Learnings Coach v2.0.0a7 (open source, MIT) from a ProbeMatrix four-level human-factors investigation. ProbeMatrix by Eyekyam: ashley@eyekyam.com</a:t>
+              <a:t>Learning purposes: not a statutory document · Generated with ProbeMatrix Learnings Coach v2.0.0a8 (open source, MIT) from a ProbeMatrix four-level human-factors investigation. ProbeMatrix by Eyekyam: ashley@eyekyam.com</a:t>
             </a:r>
             <a:endParaRPr lang="en" sz="900" dirty="0"/>
           </a:p>
@@ -3971,7 +3971,7 @@
                   <a:srgbClr val="57606A"/>
                 </a:solidFill>
               </a:rPr>
-              <a:t>Generated with ProbeMatrix Learnings Coach v2.0.0a7 (open source, MIT) from a ProbeMatrix four-level human-factors investigation. ProbeMatrix by Eyekyam: ashley@eyekyam.com</a:t>
+              <a:t>Generated with ProbeMatrix Learnings Coach v2.0.0a8 (open source, MIT) from a ProbeMatrix four-level human-factors investigation. ProbeMatrix by Eyekyam: ashley@eyekyam.com</a:t>
             </a:r>
             <a:endParaRPr lang="en" sz="1400" dirty="0"/>
           </a:p>
@@ -4014,7 +4014,7 @@
                   <a:srgbClr val="57606A"/>
                 </a:solidFill>
               </a:rPr>
-              <a:t>Learning purposes: not a statutory document · Generated with ProbeMatrix Learnings Coach v2.0.0a7 (open source, MIT) from a ProbeMatrix four-level human-factors investigation. ProbeMatrix by Eyekyam: ashley@eyekyam.com</a:t>
+              <a:t>Learning purposes: not a statutory document · Generated with ProbeMatrix Learnings Coach v2.0.0a8 (open source, MIT) from a ProbeMatrix four-level human-factors investigation. ProbeMatrix by Eyekyam: ashley@eyekyam.com</a:t>
             </a:r>
             <a:endParaRPr lang="en" sz="900" dirty="0"/>
           </a:p>

</xml_diff>